<commit_message>
chore: mac migration backup
</commit_message>
<xml_diff>
--- a/docs/meetings/2026-05-04/presentation.pptx
+++ b/docs/meetings/2026-05-04/presentation.pptx
@@ -11,7 +11,6 @@
     <p:sldId id="405" r:id="rId2"/>
     <p:sldId id="394" r:id="rId3"/>
     <p:sldId id="396" r:id="rId4"/>
-    <p:sldId id="397" r:id="rId5"/>
     <p:sldId id="406" r:id="rId6"/>
     <p:sldId id="388" r:id="rId12"/>
     <p:sldId id="408" r:id="rId19"/>
@@ -21,6 +20,7 @@
     <p:sldId id="387" r:id="rId11"/>
     <p:sldId id="404" r:id="rId13"/>
     <p:sldId id="401" r:id="rId9"/>
+    <p:sldId id="368" r:id="rId18"/>
     <p:sldId id="385" r:id="rId10"/>
     <p:sldId id="407" r:id="rId14"/>
     <p:sldId id="389" r:id="rId7"/>
@@ -7636,7 +7636,7 @@
                 <a:ea typeface="Pretendard"/>
                 <a:cs typeface="Pretendard"/>
               </a:rPr>
-              <a:t>교수님 가이드 요청 — 방향성 열린 질문</a:t>
+              <a:t>교수님 가이드 요청 — 함께 정할 결정</a:t>
             </a:r>
           </a:p>
         </p:txBody>
@@ -7679,7 +7679,7 @@
                 <a:ea typeface="Pretendard"/>
                 <a:cs typeface="Pretendard"/>
               </a:rPr>
-              <a:t>앞으로 2~3개월 방향성 설정에 도움을 구하는 4가지</a:t>
+              <a:t>Slide 4 OPEN의 결정 항목을 4개 카테고리로 묶어 의논</a:t>
             </a:r>
           </a:p>
         </p:txBody>
@@ -7844,7 +7844,7 @@
                 <a:ea typeface="Pretendard"/>
                 <a:cs typeface="Pretendard"/>
               </a:rPr>
-              <a:t>논문 타깃</a:t>
+              <a:t>제어 알고리즘</a:t>
             </a:r>
           </a:p>
         </p:txBody>
@@ -7941,7 +7941,7 @@
                 <a:ea typeface="Pretendard"/>
                 <a:cs typeface="Pretendard"/>
               </a:rPr>
-              <a:t>RA-L / IROS·ICRA /</a:t>
+              <a:t>Knee Trajectory</a:t>
             </a:r>
           </a:p>
           <a:p>
@@ -7955,7 +7955,7 @@
                 <a:ea typeface="Pretendard"/>
                 <a:cs typeface="Pretendard"/>
               </a:rPr>
-              <a:t>임상 저널 중</a:t>
+              <a:t>Reference 정의 +</a:t>
             </a:r>
           </a:p>
           <a:p>
@@ -7969,7 +7969,7 @@
                 <a:ea typeface="Pretendard"/>
                 <a:cs typeface="Pretendard"/>
               </a:rPr>
-              <a:t>어디를 우선?</a:t>
+              <a:t>Impedance K·D 동정</a:t>
             </a:r>
           </a:p>
         </p:txBody>
@@ -8080,7 +8080,7 @@
                 <a:ea typeface="Pretendard"/>
                 <a:cs typeface="Pretendard"/>
               </a:rPr>
-              <a:t>비전-IMU 융합 깊이</a:t>
+              <a:t>Vision Publish Rate</a:t>
             </a:r>
           </a:p>
         </p:txBody>
@@ -8177,7 +8177,7 @@
                 <a:ea typeface="Pretendard"/>
                 <a:cs typeface="Pretendard"/>
               </a:rPr>
-              <a:t>Static R 유지?</a:t>
+              <a:t>50–60 Hz 출발 가정</a:t>
             </a:r>
           </a:p>
           <a:p>
@@ -8191,7 +8191,7 @@
                 <a:ea typeface="Pretendard"/>
                 <a:cs typeface="Pretendard"/>
               </a:rPr>
-              <a:t>완전 VIO 까지?</a:t>
+              <a:t>실측·튜닝 검증</a:t>
             </a:r>
           </a:p>
         </p:txBody>
@@ -8413,7 +8413,7 @@
                 <a:ea typeface="Pretendard"/>
                 <a:cs typeface="Pretendard"/>
               </a:rPr>
-              <a:t>제어 검증 후 착수?</a:t>
+              <a:t>임피던스 검증 후</a:t>
             </a:r>
           </a:p>
         </p:txBody>
@@ -8524,7 +8524,7 @@
                 <a:ea typeface="Pretendard"/>
                 <a:cs typeface="Pretendard"/>
               </a:rPr>
-              <a:t>Clinical · HW 방향</a:t>
+              <a:t>논문 · 임상 방향</a:t>
             </a:r>
           </a:p>
         </p:txBody>
@@ -8621,7 +8621,7 @@
                 <a:ea typeface="Pretendard"/>
                 <a:cs typeface="Pretendard"/>
               </a:rPr>
-              <a:t>IRB 진입 시점?</a:t>
+              <a:t>RA-L / ICRA·IROS /</a:t>
             </a:r>
           </a:p>
           <a:p>
@@ -8635,7 +8635,7 @@
                 <a:ea typeface="Pretendard"/>
                 <a:cs typeface="Pretendard"/>
               </a:rPr>
-              <a:t>케이블 vs 직구동?</a:t>
+              <a:t>임상 IRB 진입 시점</a:t>
             </a:r>
           </a:p>
         </p:txBody>
@@ -11394,7 +11394,7 @@
                 <a:ea typeface="Pretendard" pitchFamily="34" charset="-122"/>
                 <a:cs typeface="Pretendard" pitchFamily="34" charset="-120"/>
               </a:rPr>
-              <a:t>사진 4장 레이아웃</a:t>
+              <a:t>★ Dataset v3 — Robustness 다양성 확보</a:t>
             </a:r>
           </a:p>
         </p:txBody>
@@ -11431,7 +11431,7 @@
                 <a:ea typeface="Pretendard" pitchFamily="34" charset="-122"/>
                 <a:cs typeface="Pretendard" pitchFamily="34" charset="-120"/>
               </a:rPr>
-              <a:t>이 슬라이드에서 전달하려는 핵심 메시지를 한 문장으로 작성하세요.</a:t>
+              <a:t>옷차림 4종 × 보행 속도 6단계 → 1,300장 / yolo26s-lower6-v3 학습 진행 중</a:t>
             </a:r>
           </a:p>
         </p:txBody>
@@ -11805,7 +11805,7 @@
                 <a:latin typeface="Pretendard" pitchFamily="34" charset="0"/>
                 <a:ea typeface="Pretendard" pitchFamily="34" charset="-122"/>
               </a:rPr>
-              <a:t>이미지 1</a:t>
+              <a:t>Sweats</a:t>
             </a:r>
           </a:p>
         </p:txBody>
@@ -11841,7 +11841,7 @@
                 <a:latin typeface="Pretendard" pitchFamily="34" charset="0"/>
                 <a:ea typeface="Pretendard" pitchFamily="34" charset="-122"/>
               </a:rPr>
-              <a:t>Fig. 1 — 그림 제목</a:t>
+              <a:t>기본 보행 (2 / 3 / 4 / 4.5 / 6 / 7 km/h)</a:t>
             </a:r>
           </a:p>
         </p:txBody>
@@ -12187,7 +12187,7 @@
                 <a:latin typeface="Pretendard" pitchFamily="34" charset="0"/>
                 <a:ea typeface="Pretendard" pitchFamily="34" charset="-122"/>
               </a:rPr>
-              <a:t>이미지 2</a:t>
+              <a:t>Tight</a:t>
             </a:r>
           </a:p>
         </p:txBody>
@@ -12223,7 +12223,7 @@
                 <a:latin typeface="Pretendard" pitchFamily="34" charset="0"/>
                 <a:ea typeface="Pretendard" pitchFamily="34" charset="-122"/>
               </a:rPr>
-              <a:t>Fig. 2 — 그림 제목</a:t>
+              <a:t>신체 윤곽 강조 (3 / 4.5 / 6 km/h)</a:t>
             </a:r>
           </a:p>
         </p:txBody>
@@ -12569,7 +12569,7 @@
                 <a:latin typeface="Pretendard" pitchFamily="34" charset="0"/>
                 <a:ea typeface="Pretendard" pitchFamily="34" charset="-122"/>
               </a:rPr>
-              <a:t>이미지 3</a:t>
+              <a:t>Shorts</a:t>
             </a:r>
           </a:p>
         </p:txBody>
@@ -12605,7 +12605,7 @@
                 <a:latin typeface="Pretendard" pitchFamily="34" charset="0"/>
                 <a:ea typeface="Pretendard" pitchFamily="34" charset="-122"/>
               </a:rPr>
-              <a:t>Fig. 3 — 그림 제목</a:t>
+              <a:t>다리 노출 (3 / 4.5 / 6 km/h)</a:t>
             </a:r>
           </a:p>
         </p:txBody>
@@ -12951,7 +12951,7 @@
                 <a:latin typeface="Pretendard" pitchFamily="34" charset="0"/>
                 <a:ea typeface="Pretendard" pitchFamily="34" charset="-122"/>
               </a:rPr>
-              <a:t>이미지 4</a:t>
+              <a:t>Exosuit</a:t>
             </a:r>
           </a:p>
         </p:txBody>
@@ -12987,7 +12987,7 @@
                 <a:latin typeface="Pretendard" pitchFamily="34" charset="0"/>
                 <a:ea typeface="Pretendard" pitchFamily="34" charset="-122"/>
               </a:rPr>
-              <a:t>Fig. 4 — 그림 제목</a:t>
+              <a:t>타겟 환경 (3 / 4.5 / 6 km/h + clip)</a:t>
             </a:r>
           </a:p>
         </p:txBody>
@@ -13089,7 +13089,7 @@
                 <a:ea typeface="Pretendard"/>
                 <a:cs typeface="Pretendard"/>
               </a:rPr>
-              <a:t>실험 로드맵 — 4단계 Evolution</a:t>
+              <a:t>실험 로드맵 — Evolution</a:t>
             </a:r>
           </a:p>
         </p:txBody>
@@ -13132,7 +13132,7 @@
                 <a:ea typeface="Pretendard"/>
                 <a:cs typeface="Pretendard"/>
               </a:rPr>
-              <a:t>44.4 ms → 13.7 ms (3.24×), motor violation 0</a:t>
+              <a:t>약 44 ms → 약 14 ms (≈ 3×) · Robustness 데이터 확보까지</a:t>
             </a:r>
           </a:p>
         </p:txBody>
@@ -13437,7 +13437,21 @@
                 <a:ea typeface="Pretendard"/>
                 <a:cs typeface="Pretendard"/>
               </a:rPr>
-              <a:t>YOLO만 50 ms 통과.</a:t>
+              <a:t>YOLO 계열만</a:t>
+            </a:r>
+          </a:p>
+          <a:p>
+            <a:pPr algn="l"/>
+            <a:r>
+              <a:rPr lang="ko-KR" altLang="en-US" sz="1400">
+                <a:solidFill>
+                  <a:srgbClr val="3D4255"/>
+                </a:solidFill>
+                <a:latin typeface="Pretendard"/>
+                <a:ea typeface="Pretendard"/>
+                <a:cs typeface="Pretendard"/>
+              </a:rPr>
+              <a:t>&lt;50 ms 통과.</a:t>
             </a:r>
           </a:p>
         </p:txBody>
@@ -13620,7 +13634,7 @@
                 <a:ea typeface="Pretendard"/>
                 <a:cs typeface="Pretendard"/>
               </a:rPr>
-              <a:t>6 kpt head.</a:t>
+              <a:t>6 kpt head로 축소.</a:t>
             </a:r>
           </a:p>
           <a:p>
@@ -13634,7 +13648,7 @@
                 <a:ea typeface="Pretendard"/>
                 <a:cs typeface="Pretendard"/>
               </a:rPr>
-              <a:t>44 → 18 ms (2.4×).</a:t>
+              <a:t>약 44 → 18 ms.</a:t>
             </a:r>
           </a:p>
           <a:p>
@@ -13648,7 +13662,7 @@
                 <a:ea typeface="Pretendard"/>
                 <a:cs typeface="Pretendard"/>
               </a:rPr>
-              <a:t>Cat 1: 연산량.</a:t>
+              <a:t>연산량 감소.</a:t>
             </a:r>
           </a:p>
         </p:txBody>
@@ -13788,7 +13802,7 @@
                 <a:ea typeface="Pretendard"/>
                 <a:cs typeface="Pretendard"/>
               </a:rPr>
-              <a:t>Pipeline</a:t>
+              <a:t>Pipeline + Stable</a:t>
             </a:r>
           </a:p>
         </p:txBody>
@@ -13831,7 +13845,7 @@
                 <a:ea typeface="Pretendard"/>
                 <a:cs typeface="Pretendard"/>
               </a:rPr>
-              <a:t>DirectTRT + C++ post.</a:t>
+              <a:t>DirectTRT + C++ post</a:t>
             </a:r>
           </a:p>
           <a:p>
@@ -13845,7 +13859,7 @@
                 <a:ea typeface="Pretendard"/>
                 <a:cs typeface="Pretendard"/>
               </a:rPr>
-              <a:t>18 → 13.7 ms / 73 FPS.</a:t>
+              <a:t>+ patch chain.</a:t>
             </a:r>
           </a:p>
           <a:p>
@@ -13859,7 +13873,7 @@
                 <a:ea typeface="Pretendard"/>
                 <a:cs typeface="Pretendard"/>
               </a:rPr>
-              <a:t>Cat 2 · 3.</a:t>
+              <a:t>약 14 ms / 80 Hz.</a:t>
             </a:r>
           </a:p>
         </p:txBody>
@@ -13999,7 +14013,7 @@
                 <a:ea typeface="Pretendard"/>
                 <a:cs typeface="Pretendard"/>
               </a:rPr>
-              <a:t>Safety</a:t>
+              <a:t>Dataset v3</a:t>
             </a:r>
           </a:p>
         </p:txBody>
@@ -14042,7 +14056,7 @@
                 <a:ea typeface="Pretendard"/>
                 <a:cs typeface="Pretendard"/>
               </a:rPr>
-              <a:t>p99 19.8 ms.</a:t>
+              <a:t>4 옷차림 × 6 속도.</a:t>
             </a:r>
           </a:p>
           <a:p>
@@ -14056,7 +14070,7 @@
                 <a:ea typeface="Pretendard"/>
                 <a:cs typeface="Pretendard"/>
               </a:rPr>
-              <a:t>violation 0.</a:t>
+              <a:t>1,300장 / v3 학습.</a:t>
             </a:r>
           </a:p>
           <a:p>
@@ -14070,7 +14084,7 @@
                 <a:ea typeface="Pretendard"/>
                 <a:cs typeface="Pretendard"/>
               </a:rPr>
-              <a:t>Cat 4 · 5 · 6.</a:t>
+              <a:t>Robustness 확보.</a:t>
             </a:r>
           </a:p>
         </p:txBody>
@@ -14557,7 +14571,7 @@
                 <a:ea typeface="Pretendard" pitchFamily="34" charset="-122"/>
                 <a:cs typeface="Pretendard" pitchFamily="34" charset="-120"/>
               </a:rPr>
-              <a:t>실시간 비전 제어의 동기와 목표</a:t>
+              <a:t>Knee 중심 비전 제어 + 함께 정할 결정</a:t>
             </a:r>
           </a:p>
         </p:txBody>
@@ -14702,7 +14716,7 @@
                 <a:ea typeface="Pretendard" pitchFamily="34" charset="-122"/>
                 <a:cs typeface="Pretendard" pitchFamily="34" charset="-120"/>
               </a:rPr>
-              <a:t>4단계 Evolution · 44.4 → 13.7 ms</a:t>
+              <a:t>Evolution + 안정 동작 + Dataset v3</a:t>
             </a:r>
           </a:p>
         </p:txBody>
@@ -14847,7 +14861,7 @@
                 <a:ea typeface="Pretendard" pitchFamily="34" charset="-122"/>
                 <a:cs typeface="Pretendard" pitchFamily="34" charset="-120"/>
               </a:rPr>
-              <a:t>왜 빨라졌는가 · 실패 교훈 · 방향성 질문</a:t>
+              <a:t>왜 빨라졌는가 · 실패 교훈 · 방향성</a:t>
             </a:r>
           </a:p>
         </p:txBody>
@@ -14992,7 +15006,7 @@
                 <a:ea typeface="Pretendard" pitchFamily="34" charset="-122"/>
                 <a:cs typeface="Pretendard" pitchFamily="34" charset="-120"/>
               </a:rPr>
-              <a:t>다음 2주 Task</a:t>
+              <a:t>다음 2주 — v3 → TRT → 실모터</a:t>
             </a:r>
           </a:p>
         </p:txBody>
@@ -15070,7 +15084,7 @@
                 <a:ea typeface="Pretendard" pitchFamily="34" charset="-122"/>
                 <a:cs typeface="Pretendard" pitchFamily="34" charset="-120"/>
               </a:rPr>
-              <a:t>연구 동기 — 왜 실시간 비전 제어인가</a:t>
+              <a:t>연구 동기 — Knee 3D Trajectory 기반 제어</a:t>
             </a:r>
           </a:p>
         </p:txBody>
@@ -15108,7 +15122,7 @@
                 <a:ea typeface="Pretendard" pitchFamily="34" charset="-122"/>
                 <a:cs typeface="Pretendard" pitchFamily="34" charset="-120"/>
               </a:rPr>
-              <a:t>보행 보조 제어의 핵심은 사용자 의도 측정. 무엇으로, 얼마나 빠르게, 얼마나 안전하게 받아오느냐가 결정한다.</a:t>
+              <a:t>케이블 드리븐 보조의 제어 입력으로 무엇을 관측하는 것이 가장 정확한가. 6 keypoint 중 가장 안정적인 Knee 한 점을 중심으로.</a:t>
             </a:r>
           </a:p>
         </p:txBody>
@@ -15208,7 +15222,7 @@
                 <a:ea typeface="Pretendard" pitchFamily="34" charset="-122"/>
                 <a:cs typeface="Pretendard" pitchFamily="34" charset="-120"/>
               </a:rPr>
-              <a:t>사용자 의도의 직접 관측</a:t>
+              <a:t>Knee 3D Trajectory — 1차 관측값</a:t>
             </a:r>
           </a:p>
         </p:txBody>
@@ -15246,7 +15260,7 @@
                 <a:ea typeface="Pretendard" pitchFamily="34" charset="-122"/>
                 <a:cs typeface="Pretendard" pitchFamily="34" charset="-120"/>
               </a:rPr>
-              <a:t>힘센서·버튼은 결과만 감지. 관절 포즈는 보행 위상·의도 그 자체.</a:t>
+              <a:t>Hip은 상체 reference 부재로 angle 미정의, Ankle은 보행 occlusion 잦음. Knee가 가장 안정·케이블 부착점과 일치 가능.</a:t>
             </a:r>
           </a:p>
         </p:txBody>
@@ -15346,7 +15360,7 @@
                 <a:ea typeface="Pretendard" pitchFamily="34" charset="-122"/>
                 <a:cs typeface="Pretendard" pitchFamily="34" charset="-120"/>
               </a:rPr>
-              <a:t>임피던스 제어의 50ms 벽</a:t>
+              <a:t>한 점으로 Gait Phase 분류</a:t>
             </a:r>
           </a:p>
         </p:txBody>
@@ -15384,7 +15398,7 @@
                 <a:ea typeface="Pretendard" pitchFamily="34" charset="-122"/>
                 <a:cs typeface="Pretendard" pitchFamily="34" charset="-120"/>
               </a:rPr>
-              <a:t>Human reaction ≒ 100ms. 센싱이 그 절반 안에 들어와야 능동 보조가 안정화.</a:t>
+              <a:t>Knee flexion peak = swing 정점, extension = stance 정점. K_stance · K_swing 위상별 gain scheduling 가능.</a:t>
             </a:r>
           </a:p>
         </p:txBody>
@@ -15484,7 +15498,7 @@
                 <a:ea typeface="Pretendard" pitchFamily="34" charset="-122"/>
                 <a:cs typeface="Pretendard" pitchFamily="34" charset="-120"/>
               </a:rPr>
-              <a:t>마커리스·비접촉 요건</a:t>
+              <a:t>임상 호환 + Robust 일반화</a:t>
             </a:r>
           </a:p>
         </p:txBody>
@@ -15522,7 +15536,7 @@
                 <a:ea typeface="Pretendard" pitchFamily="34" charset="-122"/>
                 <a:cs typeface="Pretendard" pitchFamily="34" charset="-120"/>
               </a:rPr>
-              <a:t>임상 적용 시 마커 부착·Wearable 장착 불가. 단일 카메라로 해결해야 함.</a:t>
+              <a:t>Wearable 장착·재교정 없음. Dataset v3 (4 옷차림 × 6 속도) 학습으로 다양 보행 일반화.</a:t>
             </a:r>
           </a:p>
         </p:txBody>
@@ -15697,7 +15711,7 @@
                 <a:ea typeface="Pretendard" pitchFamily="34" charset="-122"/>
                 <a:cs typeface="Pretendard" pitchFamily="34" charset="-120"/>
               </a:rPr>
-              <a:t>Real-Time Vision Control</a:t>
+              <a:t>Knee-Centered Vision Control</a:t>
             </a:r>
           </a:p>
         </p:txBody>
@@ -15735,7 +15749,7 @@
                 <a:ea typeface="Pretendard" pitchFamily="34" charset="-122"/>
                 <a:cs typeface="Pretendard" pitchFamily="34" charset="-120"/>
               </a:rPr>
-              <a:t>Fig. 1 — 사용자 의도를 관절 포즈로 추정하는 비전 제어 루프</a:t>
+              <a:t>Fig. 1 — Knee 한 점으로 임피던스 제어 루프 closing</a:t>
             </a:r>
           </a:p>
         </p:txBody>
@@ -16757,7 +16771,7 @@
                 <a:ea typeface="Pretendard" pitchFamily="34" charset="-122"/>
                 <a:cs typeface="Pretendard" pitchFamily="34" charset="-120"/>
               </a:rPr>
-              <a:t>연구 목표 — 실시간 비전 기반 제어 루프</a:t>
+              <a:t>연구 비전 — 함께 정의해 나갈 방향</a:t>
             </a:r>
           </a:p>
         </p:txBody>
@@ -16825,7 +16839,7 @@
                 <a:ea typeface="Pretendard" pitchFamily="34" charset="-122"/>
                 <a:cs typeface="Pretendard" pitchFamily="34" charset="-120"/>
               </a:rPr>
-              <a:t>OBJECTIVE</a:t>
+              <a:t>VISION</a:t>
             </a:r>
           </a:p>
         </p:txBody>
@@ -16866,7 +16880,7 @@
                 <a:ea typeface="Pretendard" pitchFamily="34" charset="-122"/>
                 <a:cs typeface="Pretendard" pitchFamily="34" charset="-120"/>
               </a:rPr>
-              <a:t>하체 6 관절 3D 포즈를 E2E &lt; 50 ms 로 공급하여 임피던스 제어의 관측값으로 사용.</a:t>
+              <a:t>Knee 3D Trajectory를 임피던스 제어의 1차 관측값으로 삼아, 사용자 의도와 동기화되는 케이블 보조 토크를 생성하는 새 제어 패러다임.</a:t>
             </a:r>
           </a:p>
         </p:txBody>
@@ -16904,7 +16918,7 @@
                 <a:ea typeface="Pretendard" pitchFamily="34" charset="-122"/>
                 <a:cs typeface="Pretendard" pitchFamily="34" charset="-120"/>
               </a:rPr>
-              <a:t>CORE STACK</a:t>
+              <a:t>CONFIRMED — 검증된 영역</a:t>
             </a:r>
           </a:p>
         </p:txBody>
@@ -16945,7 +16959,7 @@
                 <a:ea typeface="Pretendard" pitchFamily="34" charset="-122"/>
                 <a:cs typeface="Pretendard" pitchFamily="34" charset="-120"/>
               </a:rPr>
-              <a:t>ZED X Mini · YOLO26s-lower6 · TRT FP16 · 20 ms HARD LIMIT</a:t>
+              <a:t>비전 약 14 ms 처리 / Knee 3D 안정 추정 / Dataset v3 1,300장 robustness 데이터.</a:t>
             </a:r>
           </a:p>
         </p:txBody>
@@ -16983,7 +16997,7 @@
                 <a:ea typeface="Pretendard" pitchFamily="34" charset="-122"/>
                 <a:cs typeface="Pretendard" pitchFamily="34" charset="-120"/>
               </a:rPr>
-              <a:t>OUTCOME</a:t>
+              <a:t>★ OPEN — 함께 정할 결정</a:t>
             </a:r>
           </a:p>
         </p:txBody>
@@ -17024,7 +17038,7 @@
                 <a:ea typeface="Pretendard" pitchFamily="34" charset="-122"/>
                 <a:cs typeface="Pretendard" pitchFamily="34" charset="-120"/>
               </a:rPr>
-              <a:t>E2E 13.7 ms · p99 19.8 ms · motor violation 0건</a:t>
+              <a:t>Knee Trajectory Reference / Impedance K·D 동정 / Sim-to-Real RL 시점 / 논문 타깃·임상 IRB / Vision Publish Rate 확정 (50–60 Hz 출발 가정)</a:t>
             </a:r>
           </a:p>
         </p:txBody>
@@ -17341,7 +17355,7 @@
                 <a:ea typeface="Pretendard" pitchFamily="34" charset="-122"/>
                 <a:cs typeface="Pretendard" pitchFamily="34" charset="-120"/>
               </a:rPr>
-              <a:t>Pipeline</a:t>
+              <a:t>Direction</a:t>
             </a:r>
           </a:p>
         </p:txBody>
@@ -17379,7 +17393,7 @@
                 <a:ea typeface="Pretendard" pitchFamily="34" charset="-122"/>
                 <a:cs typeface="Pretendard" pitchFamily="34" charset="-120"/>
               </a:rPr>
-              <a:t>Camera → Pose → 3D → SHM → Control</a:t>
+              <a:t>Open Discussion</a:t>
             </a:r>
           </a:p>
         </p:txBody>
@@ -17417,7 +17431,7 @@
                 <a:ea typeface="Pretendard" pitchFamily="34" charset="-122"/>
                 <a:cs typeface="Pretendard" pitchFamily="34" charset="-120"/>
               </a:rPr>
-              <a:t>Fig. 2 — 전체 파이프라인 개요</a:t>
+              <a:t>Fig. 2 — 함께 다듬어야 할 결정의 영역</a:t>
             </a:r>
           </a:p>
         </p:txBody>
@@ -17835,7 +17849,7 @@
                 <a:ea typeface="Pretendard"/>
                 <a:cs typeface="Pretendard"/>
               </a:rPr>
-              <a:t>Baseline 재측정</a:t>
+              <a:t>v3 학습 완료 +</a:t>
             </a:r>
           </a:p>
           <a:p>
@@ -17849,7 +17863,7 @@
                 <a:ea typeface="Pretendard"/>
                 <a:cs typeface="Pretendard"/>
               </a:rPr>
-              <a:t>p95 / std 기록</a:t>
+              <a:t>val mAP 확인</a:t>
             </a:r>
           </a:p>
         </p:txBody>
@@ -18122,7 +18136,7 @@
                 <a:ea typeface="Pretendard"/>
                 <a:cs typeface="Pretendard"/>
               </a:rPr>
-              <a:t>좌우 비대칭</a:t>
+              <a:t>TRT FP16 export</a:t>
             </a:r>
           </a:p>
           <a:p>
@@ -18136,7 +18150,7 @@
                 <a:ea typeface="Pretendard"/>
                 <a:cs typeface="Pretendard"/>
               </a:rPr>
-              <a:t>원인 규명</a:t>
+              <a:t>+ Pipeline 적용</a:t>
             </a:r>
           </a:p>
         </p:txBody>
@@ -18409,7 +18423,7 @@
                 <a:ea typeface="Pretendard"/>
                 <a:cs typeface="Pretendard"/>
               </a:rPr>
-              <a:t>Teensy + AK60</a:t>
+              <a:t>C++ + Teensy +</a:t>
             </a:r>
           </a:p>
           <a:p>
@@ -18423,7 +18437,7 @@
                 <a:ea typeface="Pretendard"/>
                 <a:cs typeface="Pretendard"/>
               </a:rPr>
-              <a:t>70N 구동</a:t>
+              <a:t>AK60 실모터 dry-run</a:t>
             </a:r>
           </a:p>
         </p:txBody>
@@ -18696,7 +18710,7 @@
                 <a:ea typeface="Pretendard"/>
                 <a:cs typeface="Pretendard"/>
               </a:rPr>
-              <a:t>미팅 질문 정리</a:t>
+              <a:t>Knee Trajectory</a:t>
             </a:r>
           </a:p>
           <a:p>
@@ -18710,7 +18724,7 @@
                 <a:ea typeface="Pretendard"/>
                 <a:cs typeface="Pretendard"/>
               </a:rPr>
-              <a:t>+ 발표 리허설</a:t>
+              <a:t>실측 + Rate 검증</a:t>
             </a:r>
           </a:p>
         </p:txBody>
@@ -18753,7 +18767,7 @@
                 <a:ea typeface="Pretendard"/>
                 <a:cs typeface="Pretendard"/>
               </a:rPr>
-              <a:t>재측정</a:t>
+              <a:t>Train</a:t>
             </a:r>
           </a:p>
         </p:txBody>
@@ -18796,7 +18810,7 @@
                 <a:ea typeface="Pretendard"/>
                 <a:cs typeface="Pretendard"/>
               </a:rPr>
-              <a:t>캘리브</a:t>
+              <a:t>Deploy</a:t>
             </a:r>
           </a:p>
         </p:txBody>
@@ -18839,7 +18853,7 @@
                 <a:ea typeface="Pretendard"/>
                 <a:cs typeface="Pretendard"/>
               </a:rPr>
-              <a:t>실모터</a:t>
+              <a:t>Motor</a:t>
             </a:r>
           </a:p>
         </p:txBody>
@@ -18882,7 +18896,7 @@
                 <a:ea typeface="Pretendard"/>
                 <a:cs typeface="Pretendard"/>
               </a:rPr>
-              <a:t>리허설</a:t>
+              <a:t>Rate</a:t>
             </a:r>
           </a:p>
         </p:txBody>
@@ -19166,7 +19180,7 @@
                 <a:latin typeface="Pretendard" pitchFamily="34" charset="0"/>
                 <a:ea typeface="Pretendard" pitchFamily="34" charset="-122"/>
               </a:rPr>
-              <a:t>E2E mean [ms]</a:t>
+              <a:t>E2E mean</a:t>
             </a:r>
           </a:p>
         </p:txBody>
@@ -19209,7 +19223,7 @@
                 <a:latin typeface="Pretendard" pitchFamily="34" charset="0"/>
                 <a:ea typeface="Pretendard" pitchFamily="34" charset="-122"/>
               </a:rPr>
-              <a:t>35.7  (가장 빠름)</a:t>
+              <a:t>약 35 ms (가장 빠름)</a:t>
             </a:r>
           </a:p>
         </p:txBody>
@@ -19252,7 +19266,7 @@
                 <a:latin typeface="Pretendard" pitchFamily="34" charset="0"/>
                 <a:ea typeface="Pretendard" pitchFamily="34" charset="-122"/>
               </a:rPr>
-              <a:t>44.4  (&lt;50ms 아슬아슬)</a:t>
+              <a:t>약 44 ms (&lt;50 ms 아슬)</a:t>
             </a:r>
           </a:p>
         </p:txBody>
@@ -19295,7 +19309,7 @@
                 <a:latin typeface="Pretendard" pitchFamily="34" charset="0"/>
                 <a:ea typeface="Pretendard" pitchFamily="34" charset="-122"/>
               </a:rPr>
-              <a:t>63.6  /  150.5+  (실패)</a:t>
+              <a:t>약 64 / 150+ (실패)</a:t>
             </a:r>
           </a:p>
         </p:txBody>
@@ -19381,7 +19395,7 @@
                 <a:latin typeface="Pretendard" pitchFamily="34" charset="0"/>
                 <a:ea typeface="Pretendard" pitchFamily="34" charset="-122"/>
               </a:rPr>
-              <a:t>27.7</a:t>
+              <a:t>약 28</a:t>
             </a:r>
           </a:p>
         </p:txBody>
@@ -19424,7 +19438,7 @@
                 <a:latin typeface="Pretendard" pitchFamily="34" charset="0"/>
                 <a:ea typeface="Pretendard" pitchFamily="34" charset="-122"/>
               </a:rPr>
-              <a:t>22.3</a:t>
+              <a:t>약 22</a:t>
             </a:r>
           </a:p>
         </p:txBody>
@@ -19467,7 +19481,7 @@
                 <a:latin typeface="Pretendard" pitchFamily="34" charset="0"/>
                 <a:ea typeface="Pretendard" pitchFamily="34" charset="-122"/>
               </a:rPr>
-              <a:t>15.5 / 6.6</a:t>
+              <a:t>약 16 / 7</a:t>
             </a:r>
           </a:p>
         </p:txBody>
@@ -19510,7 +19524,7 @@
                 <a:latin typeface="Pretendard" pitchFamily="34" charset="0"/>
                 <a:ea typeface="Pretendard" pitchFamily="34" charset="-122"/>
               </a:rPr>
-              <a:t>E2E &lt;50ms 비율</a:t>
+              <a:t>E2E &lt;50 ms</a:t>
             </a:r>
           </a:p>
         </p:txBody>
@@ -19553,7 +19567,7 @@
                 <a:latin typeface="Pretendard" pitchFamily="34" charset="0"/>
                 <a:ea typeface="Pretendard" pitchFamily="34" charset="-122"/>
               </a:rPr>
-              <a:t>100 %</a:t>
+              <a:t>전 frame 통과</a:t>
             </a:r>
           </a:p>
         </p:txBody>
@@ -19596,7 +19610,7 @@
                 <a:latin typeface="Pretendard" pitchFamily="34" charset="0"/>
                 <a:ea typeface="Pretendard" pitchFamily="34" charset="-122"/>
               </a:rPr>
-              <a:t>99.4 %</a:t>
+              <a:t>거의 전 frame</a:t>
             </a:r>
           </a:p>
         </p:txBody>
@@ -19639,7 +19653,7 @@
                 <a:latin typeface="Pretendard" pitchFamily="34" charset="0"/>
                 <a:ea typeface="Pretendard" pitchFamily="34" charset="-122"/>
               </a:rPr>
-              <a:t>0 %</a:t>
+              <a:t>사실상 실패</a:t>
             </a:r>
           </a:p>
         </p:txBody>
@@ -19682,7 +19696,7 @@
                 <a:latin typeface="Pretendard" pitchFamily="34" charset="0"/>
                 <a:ea typeface="Pretendard" pitchFamily="34" charset="-122"/>
               </a:rPr>
-              <a:t>인식률 / Confidence</a:t>
+              <a:t>인식 / Conf</a:t>
             </a:r>
           </a:p>
         </p:txBody>
@@ -19725,7 +19739,7 @@
                 <a:latin typeface="Pretendard" pitchFamily="34" charset="0"/>
                 <a:ea typeface="Pretendard" pitchFamily="34" charset="-122"/>
               </a:rPr>
-              <a:t>100 % / 0.97</a:t>
+              <a:t>안정 / 0.97</a:t>
             </a:r>
           </a:p>
         </p:txBody>
@@ -19768,7 +19782,7 @@
                 <a:latin typeface="Pretendard" pitchFamily="34" charset="0"/>
                 <a:ea typeface="Pretendard" pitchFamily="34" charset="-122"/>
               </a:rPr>
-              <a:t>100 % / 0.99</a:t>
+              <a:t>안정 / 0.99</a:t>
             </a:r>
           </a:p>
         </p:txBody>
@@ -19811,7 +19825,7 @@
                 <a:latin typeface="Pretendard" pitchFamily="34" charset="0"/>
                 <a:ea typeface="Pretendard" pitchFamily="34" charset="-122"/>
               </a:rPr>
-              <a:t>94.4 % / 0.77</a:t>
+              <a:t>불안정 / 0.77</a:t>
             </a:r>
           </a:p>
         </p:txBody>
@@ -19925,7 +19939,7 @@
                 <a:ea typeface="Pretendard" pitchFamily="34" charset="-122"/>
                 <a:cs typeface="Pretendard" pitchFamily="34" charset="-120"/>
               </a:rPr>
-              <a:t>실험 4 — 20 ms HARD LIMIT 안전 구조</a:t>
+              <a:t>★ 안정 동작 + 제어 Publish Rate (출발선)</a:t>
             </a:r>
           </a:p>
         </p:txBody>
@@ -19963,7 +19977,7 @@
                 <a:ea typeface="Pretendard" pitchFamily="34" charset="-122"/>
                 <a:cs typeface="Pretendard" pitchFamily="34" charset="-120"/>
               </a:rPr>
-              <a:t>300초 연속 운전 · frame-skip 패턴 기반 정량적 안전 보장</a:t>
+              <a:t>Camera 120 Hz → Pipeline 약 80 Hz → Publish 50–60 Hz → C++ 100 Hz → Motor</a:t>
             </a:r>
           </a:p>
         </p:txBody>
@@ -20072,7 +20086,7 @@
                 <a:ea typeface="Pretendard" pitchFamily="34" charset="-122"/>
                 <a:cs typeface="Pretendard" pitchFamily="34" charset="-120"/>
               </a:rPr>
-              <a:t>19.8 ms</a:t>
+              <a:t>≈ 14 ms</a:t>
             </a:r>
           </a:p>
         </p:txBody>
@@ -20110,7 +20124,7 @@
                 <a:ea typeface="Pretendard" pitchFamily="34" charset="-122"/>
                 <a:cs typeface="Pretendard" pitchFamily="34" charset="-120"/>
               </a:rPr>
-              <a:t>p99 E2E Latency</a:t>
+              <a:t>처리 latency 평균</a:t>
             </a:r>
           </a:p>
         </p:txBody>
@@ -20151,7 +20165,7 @@
                 <a:ea typeface="Pretendard" pitchFamily="34" charset="-122"/>
                 <a:cs typeface="Pretendard" pitchFamily="34" charset="-120"/>
               </a:rPr>
-              <a:t>HARD LIMIT 20 ms 기준</a:t>
+              <a:t>사람 반응의 약 1/7</a:t>
             </a:r>
           </a:p>
         </p:txBody>
@@ -20260,7 +20274,7 @@
                 <a:ea typeface="Pretendard" pitchFamily="34" charset="-122"/>
                 <a:cs typeface="Pretendard" pitchFamily="34" charset="-120"/>
               </a:rPr>
-              <a:t>0.031 %</a:t>
+              <a:t>≈ 80 Hz</a:t>
             </a:r>
           </a:p>
         </p:txBody>
@@ -20298,7 +20312,7 @@
                 <a:ea typeface="Pretendard" pitchFamily="34" charset="-122"/>
                 <a:cs typeface="Pretendard" pitchFamily="34" charset="-120"/>
               </a:rPr>
-              <a:t>HARD LIMIT 초과율</a:t>
+              <a:t>Pipeline 처리 가능</a:t>
             </a:r>
           </a:p>
         </p:txBody>
@@ -20338,7 +20352,7 @@
                 <a:ea typeface="Pretendard" pitchFamily="34" charset="-122"/>
                 <a:cs typeface="Pretendard" pitchFamily="34" charset="-120"/>
               </a:rPr>
-              <a:t>93 / 300,000 frame</a:t>
+              <a:t>Publish rate에 margin</a:t>
             </a:r>
           </a:p>
         </p:txBody>
@@ -20447,7 +20461,7 @@
                 <a:ea typeface="Pretendard" pitchFamily="34" charset="-122"/>
                 <a:cs typeface="Pretendard" pitchFamily="34" charset="-120"/>
               </a:rPr>
-              <a:t>0 건</a:t>
+              <a:t>50–60 Hz</a:t>
             </a:r>
           </a:p>
         </p:txBody>
@@ -20485,7 +20499,7 @@
                 <a:ea typeface="Pretendard" pitchFamily="34" charset="-122"/>
                 <a:cs typeface="Pretendard" pitchFamily="34" charset="-120"/>
               </a:rPr>
-              <a:t>모터 도달 violation</a:t>
+              <a:t>Publish rate (출발 가정)</a:t>
             </a:r>
           </a:p>
         </p:txBody>
@@ -20525,7 +20539,7 @@
                 <a:ea typeface="Pretendard" pitchFamily="34" charset="-122"/>
                 <a:cs typeface="Pretendard" pitchFamily="34" charset="-120"/>
               </a:rPr>
-              <a:t>valid=False 로 제어 차단</a:t>
+              <a:t>확정은 실측 후</a:t>
             </a:r>
           </a:p>
         </p:txBody>
@@ -20563,7 +20577,7 @@
                 <a:ea typeface="Pretendard" pitchFamily="34" charset="-122"/>
                 <a:cs typeface="Pretendard" pitchFamily="34" charset="-120"/>
               </a:rPr>
-              <a:t>* 5-layer defense: GC off · SCHED_FIFO 90 · taskset · watchdog · 70 N clamp</a:t>
+              <a:t>* 180 s 연속 동작 검증 — Hard Limit 위반 거의 없음. 정확한 publish rate은 실측 후 확정 (slide 4 OPEN 항목)</a:t>
             </a:r>
           </a:p>
         </p:txBody>
@@ -20665,7 +20679,7 @@
                 <a:ea typeface="Pretendard"/>
                 <a:cs typeface="Pretendard"/>
               </a:rPr>
-              <a:t>종합 성과 — 3.24× 가속 + 안전 보장</a:t>
+              <a:t>종합 성과 — 약 3× 가속 + 안정 동작</a:t>
             </a:r>
           </a:p>
         </p:txBody>
@@ -20708,7 +20722,7 @@
                 <a:ea typeface="Pretendard"/>
                 <a:cs typeface="Pretendard"/>
               </a:rPr>
-              <a:t>Baseline 44.4 ms · 22 FPS → 최종 13.7 ms · 73 FPS · violation 0</a:t>
+              <a:t>Baseline 약 44 ms → 최종 약 14 ms / 약 80 Hz / 180 s 검증</a:t>
             </a:r>
           </a:p>
         </p:txBody>
@@ -20913,7 +20927,7 @@
                 <a:ea typeface="Pretendard"/>
                 <a:cs typeface="Pretendard"/>
               </a:rPr>
-              <a:t>3.24×</a:t>
+              <a:t>약 3×</a:t>
             </a:r>
           </a:p>
         </p:txBody>
@@ -20999,7 +21013,7 @@
                 <a:ea typeface="Pretendard"/>
                 <a:cs typeface="Pretendard"/>
               </a:rPr>
-              <a:t>44.4 → 13.7 ms</a:t>
+              <a:t>44 → 14 ms</a:t>
             </a:r>
           </a:p>
         </p:txBody>
@@ -21150,7 +21164,7 @@
                 <a:ea typeface="Pretendard"/>
                 <a:cs typeface="Pretendard"/>
               </a:rPr>
-              <a:t>13.7 ms</a:t>
+              <a:t>≈ 14 ms</a:t>
             </a:r>
           </a:p>
         </p:txBody>
@@ -21193,7 +21207,7 @@
                 <a:ea typeface="Pretendard"/>
                 <a:cs typeface="Pretendard"/>
               </a:rPr>
-              <a:t>Final E2E mean</a:t>
+              <a:t>Final E2E</a:t>
             </a:r>
           </a:p>
         </p:txBody>
@@ -21236,7 +21250,7 @@
                 <a:ea typeface="Pretendard"/>
                 <a:cs typeface="Pretendard"/>
               </a:rPr>
-              <a:t>Jetson 실측</a:t>
+              <a:t>Pipeline 안정</a:t>
             </a:r>
           </a:p>
         </p:txBody>
@@ -21387,7 +21401,7 @@
                 <a:ea typeface="Pretendard"/>
                 <a:cs typeface="Pretendard"/>
               </a:rPr>
-              <a:t>73 FPS</a:t>
+              <a:t>≈ 80 Hz</a:t>
             </a:r>
           </a:p>
         </p:txBody>
@@ -21473,7 +21487,7 @@
                 <a:ea typeface="Pretendard"/>
                 <a:cs typeface="Pretendard"/>
               </a:rPr>
-              <a:t>Python 단독</a:t>
+              <a:t>충분한 여유</a:t>
             </a:r>
           </a:p>
         </p:txBody>
@@ -21624,7 +21638,7 @@
                 <a:ea typeface="Pretendard"/>
                 <a:cs typeface="Pretendard"/>
               </a:rPr>
-              <a:t>0 건</a:t>
+              <a:t>거의 없음</a:t>
             </a:r>
           </a:p>
         </p:txBody>
@@ -21667,7 +21681,7 @@
                 <a:ea typeface="Pretendard"/>
                 <a:cs typeface="Pretendard"/>
               </a:rPr>
-              <a:t>Motor violation</a:t>
+              <a:t>Hard Limit 위반</a:t>
             </a:r>
           </a:p>
         </p:txBody>
@@ -21710,7 +21724,7 @@
                 <a:ea typeface="Pretendard"/>
                 <a:cs typeface="Pretendard"/>
               </a:rPr>
-              <a:t>20 ms HARD LIMIT</a:t>
+              <a:t>180 s 검증</a:t>
             </a:r>
           </a:p>
         </p:txBody>

</xml_diff>